<commit_message>
Rebuild PowerPoint deck: 7 slides, logo on title, architecture as stack rationale
</commit_message>
<xml_diff>
--- a/presentation/StockGuard-Capstone-Deck.pptx
+++ b/presentation/StockGuard-Capstone-Deck.pptx
@@ -12,7 +12,6 @@
     <p:sldId id="260" r:id="rId11"/>
     <p:sldId id="261" r:id="rId12"/>
     <p:sldId id="262" r:id="rId13"/>
-    <p:sldId id="263" r:id="rId14"/>
   </p:sldIdLst>
   <p:sldSz cx="12191695" cy="6858000" type="screen4x3"/>
   <p:notesSz cx="6858000" cy="9144000"/>
@@ -3183,16 +3182,40 @@
           </a:p>
         </p:txBody>
       </p:sp>
-      <p:sp>
-        <p:nvSpPr>
-          <p:cNvPr id="4" name="TextBox 3"/>
+      <p:pic>
+        <p:nvPicPr>
+          <p:cNvPr id="4" name="Picture 3" descr="logo-mark.png"/>
+          <p:cNvPicPr>
+            <a:picLocks noChangeAspect="1"/>
+          </p:cNvPicPr>
+          <p:nvPr/>
+        </p:nvPicPr>
+        <p:blipFill>
+          <a:blip r:embed="rId2"/>
+          <a:stretch>
+            <a:fillRect/>
+          </a:stretch>
+        </p:blipFill>
+        <p:spPr>
+          <a:xfrm>
+            <a:off x="8625535" y="1051560"/>
+            <a:ext cx="2804160" cy="2926080"/>
+          </a:xfrm>
+          <a:prstGeom prst="rect">
+            <a:avLst/>
+          </a:prstGeom>
+        </p:spPr>
+      </p:pic>
+      <p:sp>
+        <p:nvSpPr>
+          <p:cNvPr id="5" name="TextBox 4"/>
           <p:cNvSpPr txBox="1"/>
           <p:nvPr/>
         </p:nvSpPr>
         <p:spPr>
           <a:xfrm>
-            <a:off x="777240" y="1371600"/>
-            <a:ext cx="10637215" cy="3291840"/>
+            <a:off x="777240" y="1463040"/>
+            <a:ext cx="7498079" cy="3291840"/>
           </a:xfrm>
           <a:prstGeom prst="rect">
             <a:avLst/>
@@ -3214,7 +3237,7 @@
               </a:spcAft>
             </a:pPr>
             <a:r>
-              <a:rPr sz="6000" b="1" i="0">
+              <a:rPr sz="5800" b="1" i="0">
                 <a:solidFill>
                   <a:srgbClr val="1B2318"/>
                 </a:solidFill>
@@ -3233,7 +3256,7 @@
               </a:spcAft>
             </a:pPr>
             <a:r>
-              <a:rPr sz="2400" b="0" i="0">
+              <a:rPr sz="2200" b="0" i="0">
                 <a:solidFill>
                   <a:srgbClr val="3A6B49"/>
                 </a:solidFill>
@@ -3245,14 +3268,14 @@
           <a:p>
             <a:pPr algn="l">
               <a:spcBef>
-                <a:spcPts val="1800"/>
-              </a:spcBef>
-              <a:spcAft>
-                <a:spcPts val="0"/>
-              </a:spcAft>
-            </a:pPr>
-            <a:r>
-              <a:rPr sz="1600" b="0" i="0">
+                <a:spcPts val="1600"/>
+              </a:spcBef>
+              <a:spcAft>
+                <a:spcPts val="0"/>
+              </a:spcAft>
+            </a:pPr>
+            <a:r>
+              <a:rPr sz="1500" b="0" i="0">
                 <a:solidFill>
                   <a:srgbClr val="454E3E"/>
                 </a:solidFill>
@@ -3265,13 +3288,13 @@
       </p:sp>
       <p:sp>
         <p:nvSpPr>
-          <p:cNvPr id="5" name="TextBox 4"/>
+          <p:cNvPr id="6" name="TextBox 5"/>
           <p:cNvSpPr txBox="1"/>
           <p:nvPr/>
         </p:nvSpPr>
         <p:spPr>
           <a:xfrm>
-            <a:off x="777240" y="5486400"/>
+            <a:off x="777240" y="5577840"/>
             <a:ext cx="10637215" cy="822960"/>
           </a:xfrm>
           <a:prstGeom prst="rect">
@@ -3435,8 +3458,8 @@
         </p:nvSpPr>
         <p:spPr>
           <a:xfrm>
-            <a:off x="10042855" y="457200"/>
-            <a:ext cx="1371600" cy="365760"/>
+            <a:off x="9951415" y="457200"/>
+            <a:ext cx="1463040" cy="365760"/>
           </a:xfrm>
           <a:prstGeom prst="rect">
             <a:avLst/>
@@ -3464,7 +3487,7 @@
                 </a:solidFill>
                 <a:latin typeface="Consolas"/>
               </a:rPr>
-              <a:t>02 / 08</a:t>
+              <a:t>02 / 07</a:t>
             </a:r>
           </a:p>
         </p:txBody>
@@ -3820,8 +3843,8 @@
         </p:nvSpPr>
         <p:spPr>
           <a:xfrm>
-            <a:off x="10317175" y="6400800"/>
-            <a:ext cx="1097280" cy="320040"/>
+            <a:off x="10225735" y="6400800"/>
+            <a:ext cx="1188720" cy="320040"/>
           </a:xfrm>
           <a:prstGeom prst="rect">
             <a:avLst/>
@@ -3849,7 +3872,7 @@
                 </a:solidFill>
                 <a:latin typeface="Consolas"/>
               </a:rPr>
-              <a:t>02 / 08</a:t>
+              <a:t>02 / 07</a:t>
             </a:r>
           </a:p>
         </p:txBody>
@@ -3966,8 +3989,8 @@
         </p:nvSpPr>
         <p:spPr>
           <a:xfrm>
-            <a:off x="10042855" y="457200"/>
-            <a:ext cx="1371600" cy="365760"/>
+            <a:off x="9951415" y="457200"/>
+            <a:ext cx="1463040" cy="365760"/>
           </a:xfrm>
           <a:prstGeom prst="rect">
             <a:avLst/>
@@ -3995,7 +4018,7 @@
                 </a:solidFill>
                 <a:latin typeface="Consolas"/>
               </a:rPr>
-              <a:t>03 / 08</a:t>
+              <a:t>03 / 07</a:t>
             </a:r>
           </a:p>
         </p:txBody>
@@ -4724,8 +4747,8 @@
         </p:nvSpPr>
         <p:spPr>
           <a:xfrm>
-            <a:off x="10317175" y="6400800"/>
-            <a:ext cx="1097280" cy="320040"/>
+            <a:off x="10225735" y="6400800"/>
+            <a:ext cx="1188720" cy="320040"/>
           </a:xfrm>
           <a:prstGeom prst="rect">
             <a:avLst/>
@@ -4753,7 +4776,7 @@
                 </a:solidFill>
                 <a:latin typeface="Consolas"/>
               </a:rPr>
-              <a:t>03 / 08</a:t>
+              <a:t>03 / 07</a:t>
             </a:r>
           </a:p>
         </p:txBody>
@@ -4857,7 +4880,7 @@
                 </a:solidFill>
                 <a:latin typeface="Consolas"/>
               </a:rPr>
-              <a:t>ARCHITECTURE &amp; THE DECISION THAT MATTERS MOST</a:t>
+              <a:t>ARCHITECTURE</a:t>
             </a:r>
           </a:p>
         </p:txBody>
@@ -4870,8 +4893,8 @@
         </p:nvSpPr>
         <p:spPr>
           <a:xfrm>
-            <a:off x="10042855" y="457200"/>
-            <a:ext cx="1371600" cy="365760"/>
+            <a:off x="9951415" y="457200"/>
+            <a:ext cx="1463040" cy="365760"/>
           </a:xfrm>
           <a:prstGeom prst="rect">
             <a:avLst/>
@@ -4899,21 +4922,63 @@
                 </a:solidFill>
                 <a:latin typeface="Consolas"/>
               </a:rPr>
-              <a:t>04 / 08</a:t>
-            </a:r>
-          </a:p>
-        </p:txBody>
-      </p:sp>
-      <p:sp>
-        <p:nvSpPr>
-          <p:cNvPr id="5" name="Rectangle 4"/>
+              <a:t>04 / 07</a:t>
+            </a:r>
+          </a:p>
+        </p:txBody>
+      </p:sp>
+      <p:sp>
+        <p:nvSpPr>
+          <p:cNvPr id="5" name="TextBox 4"/>
+          <p:cNvSpPr txBox="1"/>
+          <p:nvPr/>
+        </p:nvSpPr>
+        <p:spPr>
+          <a:xfrm>
+            <a:off x="777240" y="914400"/>
+            <a:ext cx="10637215" cy="822960"/>
+          </a:xfrm>
+          <a:prstGeom prst="rect">
+            <a:avLst/>
+          </a:prstGeom>
+          <a:noFill/>
+        </p:spPr>
+        <p:txBody>
+          <a:bodyPr wrap="square" anchor="t">
+            <a:spAutoFit/>
+          </a:bodyPr>
+          <a:lstStyle/>
+          <a:p>
+            <a:pPr algn="l">
+              <a:spcBef>
+                <a:spcPts val="600"/>
+              </a:spcBef>
+              <a:spcAft>
+                <a:spcPts val="0"/>
+              </a:spcAft>
+            </a:pPr>
+            <a:r>
+              <a:rPr sz="2600" b="1" i="0">
+                <a:solidFill>
+                  <a:srgbClr val="1B2318"/>
+                </a:solidFill>
+                <a:latin typeface="Georgia"/>
+              </a:rPr>
+              <a:t>Three layers — each chosen for a reason.</a:t>
+            </a:r>
+          </a:p>
+        </p:txBody>
+      </p:sp>
+      <p:sp>
+        <p:nvSpPr>
+          <p:cNvPr id="6" name="Rectangle 5"/>
           <p:cNvSpPr/>
           <p:nvPr/>
         </p:nvSpPr>
         <p:spPr>
           <a:xfrm>
-            <a:off x="777240" y="1051560"/>
-            <a:ext cx="3383280" cy="868680"/>
+            <a:off x="777240" y="1783080"/>
+            <a:ext cx="3200400" cy="1371600"/>
           </a:xfrm>
           <a:prstGeom prst="rect">
             <a:avLst/>
@@ -4943,10 +5008,10 @@
           </a:fontRef>
         </p:style>
         <p:txBody>
-          <a:bodyPr rtlCol="0" anchor="ctr"/>
-          <a:lstStyle/>
-          <a:p>
-            <a:pPr algn="ctr">
+          <a:bodyPr rtlCol="0" anchor="ctr" wrap="square" lIns="127000" rIns="101600"/>
+          <a:lstStyle/>
+          <a:p>
+            <a:pPr algn="l">
               <a:spcBef>
                 <a:spcPts val="600"/>
               </a:spcBef>
@@ -4955,46 +5020,27 @@
               </a:spcAft>
             </a:pPr>
             <a:r>
-              <a:rPr sz="1400" b="1" i="0">
+              <a:rPr sz="1450" b="1" i="0">
                 <a:solidFill>
                   <a:srgbClr val="1B2318"/>
                 </a:solidFill>
                 <a:latin typeface="Consolas"/>
               </a:rPr>
-              <a:t>React (Vite)</a:t>
-            </a:r>
-          </a:p>
-          <a:p>
-            <a:pPr algn="ctr">
-              <a:spcBef>
-                <a:spcPts val="200"/>
-              </a:spcBef>
-              <a:spcAft>
-                <a:spcPts val="0"/>
-              </a:spcAft>
-            </a:pPr>
-            <a:r>
-              <a:rPr sz="950" b="0" i="0">
-                <a:solidFill>
-                  <a:srgbClr val="8B8676"/>
-                </a:solidFill>
-                <a:latin typeface="Consolas"/>
-              </a:rPr>
-              <a:t>MUI · Formik / Yup</a:t>
-            </a:r>
-          </a:p>
-        </p:txBody>
-      </p:sp>
-      <p:sp>
-        <p:nvSpPr>
-          <p:cNvPr id="6" name="TextBox 5"/>
+              <a:t>React (with Vite)</a:t>
+            </a:r>
+          </a:p>
+        </p:txBody>
+      </p:sp>
+      <p:sp>
+        <p:nvSpPr>
+          <p:cNvPr id="7" name="TextBox 6"/>
           <p:cNvSpPr txBox="1"/>
           <p:nvPr/>
         </p:nvSpPr>
         <p:spPr>
           <a:xfrm>
-            <a:off x="4114800" y="1234440"/>
-            <a:ext cx="457200" cy="457200"/>
+            <a:off x="4343400" y="1783080"/>
+            <a:ext cx="7071055" cy="1371600"/>
           </a:xfrm>
           <a:prstGeom prst="rect">
             <a:avLst/>
@@ -5002,7 +5048,7 @@
           <a:noFill/>
         </p:spPr>
         <p:txBody>
-          <a:bodyPr wrap="none">
+          <a:bodyPr wrap="square" anchor="ctr">
             <a:spAutoFit/>
           </a:bodyPr>
           <a:lstStyle/>
@@ -5016,33 +5062,33 @@
               </a:spcAft>
             </a:pPr>
             <a:r>
-              <a:rPr sz="1800" b="0" i="0">
-                <a:solidFill>
-                  <a:srgbClr val="8B8676"/>
+              <a:rPr sz="1250" b="0" i="0">
+                <a:solidFill>
+                  <a:srgbClr val="454E3E"/>
                 </a:solidFill>
                 <a:latin typeface="Calibri"/>
               </a:rPr>
-              <a:t>→</a:t>
-            </a:r>
-          </a:p>
-        </p:txBody>
-      </p:sp>
-      <p:sp>
-        <p:nvSpPr>
-          <p:cNvPr id="7" name="Rectangle 6"/>
+              <a:t>The farmer side is a multi-step journey and the admin side is a data-heavy console — a component model keeps both maintainable, and Vite gives instant feedback while building. MUI + Formik/Yup for accessible forms that validate before they submit.</a:t>
+            </a:r>
+          </a:p>
+        </p:txBody>
+      </p:sp>
+      <p:sp>
+        <p:nvSpPr>
+          <p:cNvPr id="8" name="Rectangle 7"/>
           <p:cNvSpPr/>
           <p:nvPr/>
         </p:nvSpPr>
         <p:spPr>
           <a:xfrm>
-            <a:off x="4544568" y="1051560"/>
-            <a:ext cx="3383280" cy="868680"/>
+            <a:off x="777240" y="3319272"/>
+            <a:ext cx="3200400" cy="1371600"/>
           </a:xfrm>
           <a:prstGeom prst="rect">
             <a:avLst/>
           </a:prstGeom>
           <a:solidFill>
-            <a:srgbClr val="F6F4EE"/>
+            <a:srgbClr val="FFFEFB"/>
           </a:solidFill>
           <a:ln w="12700">
             <a:solidFill>
@@ -5066,10 +5112,10 @@
           </a:fontRef>
         </p:style>
         <p:txBody>
-          <a:bodyPr rtlCol="0" anchor="ctr"/>
-          <a:lstStyle/>
-          <a:p>
-            <a:pPr algn="ctr">
+          <a:bodyPr rtlCol="0" anchor="ctr" wrap="square" lIns="127000" rIns="101600"/>
+          <a:lstStyle/>
+          <a:p>
+            <a:pPr algn="l">
               <a:spcBef>
                 <a:spcPts val="600"/>
               </a:spcBef>
@@ -5078,46 +5124,27 @@
               </a:spcAft>
             </a:pPr>
             <a:r>
-              <a:rPr sz="1400" b="1" i="0">
+              <a:rPr sz="1450" b="1" i="0">
                 <a:solidFill>
                   <a:srgbClr val="1B2318"/>
                 </a:solidFill>
                 <a:latin typeface="Consolas"/>
               </a:rPr>
-              <a:t>Flask REST API</a:t>
-            </a:r>
-          </a:p>
-          <a:p>
-            <a:pPr algn="ctr">
-              <a:spcBef>
-                <a:spcPts val="200"/>
-              </a:spcBef>
-              <a:spcAft>
-                <a:spcPts val="0"/>
-              </a:spcAft>
-            </a:pPr>
-            <a:r>
-              <a:rPr sz="950" b="0" i="0">
-                <a:solidFill>
-                  <a:srgbClr val="8B8676"/>
-                </a:solidFill>
-                <a:latin typeface="Consolas"/>
-              </a:rPr>
-              <a:t>blueprint per resource · JWT</a:t>
-            </a:r>
-          </a:p>
-        </p:txBody>
-      </p:sp>
-      <p:sp>
-        <p:nvSpPr>
-          <p:cNvPr id="8" name="TextBox 7"/>
+              <a:t>Flask REST API (Python)</a:t>
+            </a:r>
+          </a:p>
+        </p:txBody>
+      </p:sp>
+      <p:sp>
+        <p:nvSpPr>
+          <p:cNvPr id="9" name="TextBox 8"/>
           <p:cNvSpPr txBox="1"/>
           <p:nvPr/>
         </p:nvSpPr>
         <p:spPr>
           <a:xfrm>
-            <a:off x="7882128" y="1234440"/>
-            <a:ext cx="457200" cy="457200"/>
+            <a:off x="4343400" y="3319272"/>
+            <a:ext cx="7071055" cy="1371600"/>
           </a:xfrm>
           <a:prstGeom prst="rect">
             <a:avLst/>
@@ -5125,7 +5152,7 @@
           <a:noFill/>
         </p:spPr>
         <p:txBody>
-          <a:bodyPr wrap="none">
+          <a:bodyPr wrap="square" anchor="ctr">
             <a:spAutoFit/>
           </a:bodyPr>
           <a:lstStyle/>
@@ -5139,27 +5166,27 @@
               </a:spcAft>
             </a:pPr>
             <a:r>
-              <a:rPr sz="1800" b="0" i="0">
-                <a:solidFill>
-                  <a:srgbClr val="8B8676"/>
+              <a:rPr sz="1250" b="0" i="0">
+                <a:solidFill>
+                  <a:srgbClr val="454E3E"/>
                 </a:solidFill>
                 <a:latin typeface="Calibri"/>
               </a:rPr>
-              <a:t>→</a:t>
-            </a:r>
-          </a:p>
-        </p:txBody>
-      </p:sp>
-      <p:sp>
-        <p:nvSpPr>
-          <p:cNvPr id="9" name="Rectangle 8"/>
+              <a:t>Small and explicit: one blueprint per resource keeps the API readable and the business rules easy to find. SQLAlchemy for safe, parameterised queries; Flask-JWT-Extended for stateless auth where every route derives the farm from the token.</a:t>
+            </a:r>
+          </a:p>
+        </p:txBody>
+      </p:sp>
+      <p:sp>
+        <p:nvSpPr>
+          <p:cNvPr id="10" name="Rectangle 9"/>
           <p:cNvSpPr/>
           <p:nvPr/>
         </p:nvSpPr>
         <p:spPr>
           <a:xfrm>
-            <a:off x="8311896" y="1051560"/>
-            <a:ext cx="3383280" cy="868680"/>
+            <a:off x="777240" y="4855464"/>
+            <a:ext cx="3200400" cy="1371600"/>
           </a:xfrm>
           <a:prstGeom prst="rect">
             <a:avLst/>
@@ -5189,10 +5216,10 @@
           </a:fontRef>
         </p:style>
         <p:txBody>
-          <a:bodyPr rtlCol="0" anchor="ctr"/>
-          <a:lstStyle/>
-          <a:p>
-            <a:pPr algn="ctr">
+          <a:bodyPr rtlCol="0" anchor="ctr" wrap="square" lIns="127000" rIns="101600"/>
+          <a:lstStyle/>
+          <a:p>
+            <a:pPr algn="l">
               <a:spcBef>
                 <a:spcPts val="600"/>
               </a:spcBef>
@@ -5201,7 +5228,7 @@
               </a:spcAft>
             </a:pPr>
             <a:r>
-              <a:rPr sz="1400" b="1" i="0">
+              <a:rPr sz="1450" b="1" i="0">
                 <a:solidFill>
                   <a:srgbClr val="1B2318"/>
                 </a:solidFill>
@@ -5210,37 +5237,18 @@
               <a:t>Microsoft SQL Server</a:t>
             </a:r>
           </a:p>
-          <a:p>
-            <a:pPr algn="ctr">
-              <a:spcBef>
-                <a:spcPts val="200"/>
-              </a:spcBef>
-              <a:spcAft>
-                <a:spcPts val="0"/>
-              </a:spcAft>
-            </a:pPr>
-            <a:r>
-              <a:rPr sz="950" b="0" i="0">
-                <a:solidFill>
-                  <a:srgbClr val="8B8676"/>
-                </a:solidFill>
-                <a:latin typeface="Consolas"/>
-              </a:rPr>
-              <a:t>SQLAlchemy ORM</a:t>
-            </a:r>
-          </a:p>
-        </p:txBody>
-      </p:sp>
-      <p:sp>
-        <p:nvSpPr>
-          <p:cNvPr id="10" name="TextBox 9"/>
+        </p:txBody>
+      </p:sp>
+      <p:sp>
+        <p:nvSpPr>
+          <p:cNvPr id="11" name="TextBox 10"/>
           <p:cNvSpPr txBox="1"/>
           <p:nvPr/>
         </p:nvSpPr>
         <p:spPr>
           <a:xfrm>
-            <a:off x="777240" y="2240280"/>
-            <a:ext cx="10637215" cy="1051560"/>
+            <a:off x="4343400" y="4855464"/>
+            <a:ext cx="7071055" cy="1371600"/>
           </a:xfrm>
           <a:prstGeom prst="rect">
             <a:avLst/>
@@ -5248,7 +5256,7 @@
           <a:noFill/>
         </p:spPr>
         <p:txBody>
-          <a:bodyPr wrap="square" anchor="t">
+          <a:bodyPr wrap="square" anchor="ctr">
             <a:spAutoFit/>
           </a:bodyPr>
           <a:lstStyle/>
@@ -5262,27 +5270,27 @@
               </a:spcAft>
             </a:pPr>
             <a:r>
-              <a:rPr sz="1400" b="0" i="0">
+              <a:rPr sz="1250" b="0" i="0">
                 <a:solidFill>
                   <a:srgbClr val="454E3E"/>
                 </a:solidFill>
                 <a:latin typeface="Calibri"/>
               </a:rPr>
-              <a:t>Every protected route derives the farm from the JWT, never from the request — a client can't act on another farm by editing a URL or body. Cross-farm reads return 404, not 403.</a:t>
-            </a:r>
-          </a:p>
-        </p:txBody>
-      </p:sp>
-      <p:sp>
-        <p:nvSpPr>
-          <p:cNvPr id="11" name="TextBox 10"/>
+              <a:t>The domain is naturally relational — farm → animals → inspections → claims, plus policies and payments — and it moves money and policy state, so foreign keys, constraints and transactions doing the enforcing matters more than raw flexibility.</a:t>
+            </a:r>
+          </a:p>
+        </p:txBody>
+      </p:sp>
+      <p:sp>
+        <p:nvSpPr>
+          <p:cNvPr id="12" name="TextBox 11"/>
           <p:cNvSpPr txBox="1"/>
           <p:nvPr/>
         </p:nvSpPr>
         <p:spPr>
           <a:xfrm>
-            <a:off x="777240" y="3429000"/>
-            <a:ext cx="10637215" cy="365760"/>
+            <a:off x="777240" y="6400800"/>
+            <a:ext cx="10637215" cy="320040"/>
           </a:xfrm>
           <a:prstGeom prst="rect">
             <a:avLst/>
@@ -5304,207 +5312,27 @@
               </a:spcAft>
             </a:pPr>
             <a:r>
-              <a:rPr sz="1100" b="1" i="0">
+              <a:rPr sz="900" b="0" i="0">
                 <a:solidFill>
                   <a:srgbClr val="8B8676"/>
                 </a:solidFill>
                 <a:latin typeface="Consolas"/>
               </a:rPr>
-              <a:t>A CLAIM PAYS OUT ONLY IF ALL THREE SERVER-ENFORCED CHECKS PASS</a:t>
-            </a:r>
-          </a:p>
-        </p:txBody>
-      </p:sp>
-      <p:sp>
-        <p:nvSpPr>
-          <p:cNvPr id="12" name="Rectangle 11"/>
-          <p:cNvSpPr/>
-          <p:nvPr/>
-        </p:nvSpPr>
-        <p:spPr>
-          <a:xfrm>
-            <a:off x="777240" y="3840480"/>
-            <a:ext cx="10637215" cy="566928"/>
-          </a:xfrm>
-          <a:prstGeom prst="rect">
-            <a:avLst/>
-          </a:prstGeom>
-          <a:solidFill>
-            <a:srgbClr val="F0E6DA"/>
-          </a:solidFill>
-          <a:ln>
-            <a:noFill/>
-          </a:ln>
-          <a:effectLst/>
-        </p:spPr>
-        <p:style>
-          <a:lnRef idx="1">
-            <a:schemeClr val="accent1"/>
-          </a:lnRef>
-          <a:fillRef idx="3">
-            <a:schemeClr val="accent1"/>
-          </a:fillRef>
-          <a:effectRef idx="2">
-            <a:schemeClr val="accent1"/>
-          </a:effectRef>
-          <a:fontRef idx="minor">
-            <a:schemeClr val="lt1"/>
-          </a:fontRef>
-        </p:style>
-        <p:txBody>
-          <a:bodyPr rtlCol="0" anchor="ctr" lIns="127000"/>
-          <a:lstStyle/>
-          <a:p>
-            <a:pPr algn="l">
-              <a:spcBef>
-                <a:spcPts val="600"/>
-              </a:spcBef>
-              <a:spcAft>
-                <a:spcPts val="0"/>
-              </a:spcAft>
-            </a:pPr>
-            <a:r>
-              <a:rPr sz="1350" b="0" i="0">
-                <a:solidFill>
-                  <a:srgbClr val="1B2318"/>
-                </a:solidFill>
-                <a:latin typeface="Calibri"/>
-              </a:rPr>
-              <a:t>1    The farm's policy status is Active</a:t>
-            </a:r>
-          </a:p>
-        </p:txBody>
-      </p:sp>
-      <p:sp>
-        <p:nvSpPr>
-          <p:cNvPr id="13" name="Rectangle 12"/>
-          <p:cNvSpPr/>
-          <p:nvPr/>
-        </p:nvSpPr>
-        <p:spPr>
-          <a:xfrm>
-            <a:off x="777240" y="4498848"/>
-            <a:ext cx="10637215" cy="566928"/>
-          </a:xfrm>
-          <a:prstGeom prst="rect">
-            <a:avLst/>
-          </a:prstGeom>
-          <a:solidFill>
-            <a:srgbClr val="F0E6DA"/>
-          </a:solidFill>
-          <a:ln>
-            <a:noFill/>
-          </a:ln>
-          <a:effectLst/>
-        </p:spPr>
-        <p:style>
-          <a:lnRef idx="1">
-            <a:schemeClr val="accent1"/>
-          </a:lnRef>
-          <a:fillRef idx="3">
-            <a:schemeClr val="accent1"/>
-          </a:fillRef>
-          <a:effectRef idx="2">
-            <a:schemeClr val="accent1"/>
-          </a:effectRef>
-          <a:fontRef idx="minor">
-            <a:schemeClr val="lt1"/>
-          </a:fontRef>
-        </p:style>
-        <p:txBody>
-          <a:bodyPr rtlCol="0" anchor="ctr" lIns="127000"/>
-          <a:lstStyle/>
-          <a:p>
-            <a:pPr algn="l">
-              <a:spcBef>
-                <a:spcPts val="600"/>
-              </a:spcBef>
-              <a:spcAft>
-                <a:spcPts val="0"/>
-              </a:spcAft>
-            </a:pPr>
-            <a:r>
-              <a:rPr sz="1350" b="0" i="0">
-                <a:solidFill>
-                  <a:srgbClr val="1B2318"/>
-                </a:solidFill>
-                <a:latin typeface="Calibri"/>
-              </a:rPr>
-              <a:t>2    That specific animal's inspection is Approved</a:t>
-            </a:r>
-          </a:p>
-        </p:txBody>
-      </p:sp>
-      <p:sp>
-        <p:nvSpPr>
-          <p:cNvPr id="14" name="Rectangle 13"/>
-          <p:cNvSpPr/>
-          <p:nvPr/>
-        </p:nvSpPr>
-        <p:spPr>
-          <a:xfrm>
-            <a:off x="777240" y="5157216"/>
-            <a:ext cx="10637215" cy="566928"/>
-          </a:xfrm>
-          <a:prstGeom prst="rect">
-            <a:avLst/>
-          </a:prstGeom>
-          <a:solidFill>
-            <a:srgbClr val="F0E6DA"/>
-          </a:solidFill>
-          <a:ln>
-            <a:noFill/>
-          </a:ln>
-          <a:effectLst/>
-        </p:spPr>
-        <p:style>
-          <a:lnRef idx="1">
-            <a:schemeClr val="accent1"/>
-          </a:lnRef>
-          <a:fillRef idx="3">
-            <a:schemeClr val="accent1"/>
-          </a:fillRef>
-          <a:effectRef idx="2">
-            <a:schemeClr val="accent1"/>
-          </a:effectRef>
-          <a:fontRef idx="minor">
-            <a:schemeClr val="lt1"/>
-          </a:fontRef>
-        </p:style>
-        <p:txBody>
-          <a:bodyPr rtlCol="0" anchor="ctr" lIns="127000"/>
-          <a:lstStyle/>
-          <a:p>
-            <a:pPr algn="l">
-              <a:spcBef>
-                <a:spcPts val="600"/>
-              </a:spcBef>
-              <a:spcAft>
-                <a:spcPts val="0"/>
-              </a:spcAft>
-            </a:pPr>
-            <a:r>
-              <a:rPr sz="1350" b="0" i="0">
-                <a:solidFill>
-                  <a:srgbClr val="1B2318"/>
-                </a:solidFill>
-                <a:latin typeface="Calibri"/>
-              </a:rPr>
-              <a:t>3    Claim amount ≤ the admin-approved insured value</a:t>
-            </a:r>
-          </a:p>
-        </p:txBody>
-      </p:sp>
-      <p:sp>
-        <p:nvSpPr>
-          <p:cNvPr id="15" name="TextBox 14"/>
+              <a:t>StockGuard   ·   Thembelihle Zulu   ·   Sanlam 2026 Capstone</a:t>
+            </a:r>
+          </a:p>
+        </p:txBody>
+      </p:sp>
+      <p:sp>
+        <p:nvSpPr>
+          <p:cNvPr id="13" name="TextBox 12"/>
           <p:cNvSpPr txBox="1"/>
           <p:nvPr/>
         </p:nvSpPr>
         <p:spPr>
           <a:xfrm>
-            <a:off x="777240" y="5943600"/>
-            <a:ext cx="10637215" cy="365760"/>
+            <a:off x="10225735" y="6400800"/>
+            <a:ext cx="1188720" cy="320040"/>
           </a:xfrm>
           <a:prstGeom prst="rect">
             <a:avLst/>
@@ -5517,7 +5345,7 @@
           </a:bodyPr>
           <a:lstStyle/>
           <a:p>
-            <a:pPr algn="l">
+            <a:pPr algn="r">
               <a:spcBef>
                 <a:spcPts val="600"/>
               </a:spcBef>
@@ -5526,97 +5354,13 @@
               </a:spcAft>
             </a:pPr>
             <a:r>
-              <a:rPr sz="1100" b="0" i="0">
-                <a:solidFill>
-                  <a:srgbClr val="3A6B49"/>
+              <a:rPr sz="900" b="0" i="0">
+                <a:solidFill>
+                  <a:srgbClr val="8B8676"/>
                 </a:solidFill>
                 <a:latin typeface="Consolas"/>
               </a:rPr>
-              <a:t>Mocked on purpose: payment — the data model already matches a real gateway</a:t>
-            </a:r>
-          </a:p>
-        </p:txBody>
-      </p:sp>
-      <p:sp>
-        <p:nvSpPr>
-          <p:cNvPr id="16" name="TextBox 15"/>
-          <p:cNvSpPr txBox="1"/>
-          <p:nvPr/>
-        </p:nvSpPr>
-        <p:spPr>
-          <a:xfrm>
-            <a:off x="777240" y="6400800"/>
-            <a:ext cx="10637215" cy="320040"/>
-          </a:xfrm>
-          <a:prstGeom prst="rect">
-            <a:avLst/>
-          </a:prstGeom>
-          <a:noFill/>
-        </p:spPr>
-        <p:txBody>
-          <a:bodyPr wrap="square" anchor="t">
-            <a:spAutoFit/>
-          </a:bodyPr>
-          <a:lstStyle/>
-          <a:p>
-            <a:pPr algn="l">
-              <a:spcBef>
-                <a:spcPts val="600"/>
-              </a:spcBef>
-              <a:spcAft>
-                <a:spcPts val="0"/>
-              </a:spcAft>
-            </a:pPr>
-            <a:r>
-              <a:rPr sz="900" b="0" i="0">
-                <a:solidFill>
-                  <a:srgbClr val="8B8676"/>
-                </a:solidFill>
-                <a:latin typeface="Consolas"/>
-              </a:rPr>
-              <a:t>StockGuard   ·   Thembelihle Zulu   ·   Sanlam 2026 Capstone</a:t>
-            </a:r>
-          </a:p>
-        </p:txBody>
-      </p:sp>
-      <p:sp>
-        <p:nvSpPr>
-          <p:cNvPr id="17" name="TextBox 16"/>
-          <p:cNvSpPr txBox="1"/>
-          <p:nvPr/>
-        </p:nvSpPr>
-        <p:spPr>
-          <a:xfrm>
-            <a:off x="10317175" y="6400800"/>
-            <a:ext cx="1097280" cy="320040"/>
-          </a:xfrm>
-          <a:prstGeom prst="rect">
-            <a:avLst/>
-          </a:prstGeom>
-          <a:noFill/>
-        </p:spPr>
-        <p:txBody>
-          <a:bodyPr wrap="square" anchor="t">
-            <a:spAutoFit/>
-          </a:bodyPr>
-          <a:lstStyle/>
-          <a:p>
-            <a:pPr algn="r">
-              <a:spcBef>
-                <a:spcPts val="600"/>
-              </a:spcBef>
-              <a:spcAft>
-                <a:spcPts val="0"/>
-              </a:spcAft>
-            </a:pPr>
-            <a:r>
-              <a:rPr sz="900" b="0" i="0">
-                <a:solidFill>
-                  <a:srgbClr val="8B8676"/>
-                </a:solidFill>
-                <a:latin typeface="Consolas"/>
-              </a:rPr>
-              <a:t>04 / 08</a:t>
+              <a:t>04 / 07</a:t>
             </a:r>
           </a:p>
         </p:txBody>
@@ -5979,8 +5723,8 @@
         </p:nvSpPr>
         <p:spPr>
           <a:xfrm>
-            <a:off x="10317175" y="6400800"/>
-            <a:ext cx="1097280" cy="320040"/>
+            <a:off x="10225735" y="6400800"/>
+            <a:ext cx="1188720" cy="320040"/>
           </a:xfrm>
           <a:prstGeom prst="rect">
             <a:avLst/>
@@ -6008,7 +5752,7 @@
                 </a:solidFill>
                 <a:latin typeface="Consolas"/>
               </a:rPr>
-              <a:t>05 / 08</a:t>
+              <a:t>05 / 07</a:t>
             </a:r>
           </a:p>
         </p:txBody>
@@ -6125,8 +5869,8 @@
         </p:nvSpPr>
         <p:spPr>
           <a:xfrm>
-            <a:off x="10042855" y="457200"/>
-            <a:ext cx="1371600" cy="365760"/>
+            <a:off x="9951415" y="457200"/>
+            <a:ext cx="1463040" cy="365760"/>
           </a:xfrm>
           <a:prstGeom prst="rect">
             <a:avLst/>
@@ -6154,7 +5898,7 @@
                 </a:solidFill>
                 <a:latin typeface="Consolas"/>
               </a:rPr>
-              <a:t>06 / 08</a:t>
+              <a:t>06 / 07</a:t>
             </a:r>
           </a:p>
         </p:txBody>
@@ -6512,8 +6256,8 @@
         </p:nvSpPr>
         <p:spPr>
           <a:xfrm>
-            <a:off x="10317175" y="6400800"/>
-            <a:ext cx="1097280" cy="320040"/>
+            <a:off x="10225735" y="6400800"/>
+            <a:ext cx="1188720" cy="320040"/>
           </a:xfrm>
           <a:prstGeom prst="rect">
             <a:avLst/>
@@ -6541,7 +6285,7 @@
                 </a:solidFill>
                 <a:latin typeface="Consolas"/>
               </a:rPr>
-              <a:t>06 / 08</a:t>
+              <a:t>06 / 07</a:t>
             </a:r>
           </a:p>
         </p:txBody>
@@ -6645,7 +6389,7 @@
                 </a:solidFill>
                 <a:latin typeface="Consolas"/>
               </a:rPr>
-              <a:t>DEPLOYMENT &amp; DELIVERY EVIDENCE</a:t>
+              <a:t>PERSONAL REFLECTION</a:t>
             </a:r>
           </a:p>
         </p:txBody>
@@ -6658,8 +6402,8 @@
         </p:nvSpPr>
         <p:spPr>
           <a:xfrm>
-            <a:off x="10042855" y="457200"/>
-            <a:ext cx="1371600" cy="365760"/>
+            <a:off x="9951415" y="457200"/>
+            <a:ext cx="1463040" cy="365760"/>
           </a:xfrm>
           <a:prstGeom prst="rect">
             <a:avLst/>
@@ -6687,7 +6431,7 @@
                 </a:solidFill>
                 <a:latin typeface="Consolas"/>
               </a:rPr>
-              <a:t>07 / 08</a:t>
+              <a:t>07 / 07</a:t>
             </a:r>
           </a:p>
         </p:txBody>
@@ -6700,8 +6444,8 @@
         </p:nvSpPr>
         <p:spPr>
           <a:xfrm>
-            <a:off x="777240" y="960120"/>
-            <a:ext cx="10637215" cy="914400"/>
+            <a:off x="777240" y="914400"/>
+            <a:ext cx="10637215" cy="777240"/>
           </a:xfrm>
           <a:prstGeom prst="rect">
             <a:avLst/>
@@ -6729,7 +6473,7 @@
                 </a:solidFill>
                 <a:latin typeface="Georgia"/>
               </a:rPr>
-              <a:t>A reproducible stack now; the cloud pipeline built on the training.</a:t>
+              <a:t>What the training changed about how I work.</a:t>
             </a:r>
           </a:p>
         </p:txBody>
@@ -6742,8 +6486,8 @@
         </p:nvSpPr>
         <p:spPr>
           <a:xfrm>
-            <a:off x="777240" y="2103120"/>
-            <a:ext cx="5486400" cy="2743200"/>
+            <a:off x="777240" y="1737360"/>
+            <a:ext cx="10637215" cy="1143000"/>
           </a:xfrm>
           <a:prstGeom prst="rect">
             <a:avLst/>
@@ -6761,74 +6505,36 @@
                 <a:spcPts val="600"/>
               </a:spcBef>
               <a:spcAft>
-                <a:spcPts val="400"/>
-              </a:spcAft>
-            </a:pPr>
-            <a:r>
-              <a:rPr sz="1100" b="1" i="0">
-                <a:solidFill>
-                  <a:srgbClr val="8B8676"/>
+                <a:spcPts val="200"/>
+              </a:spcAft>
+            </a:pPr>
+            <a:r>
+              <a:rPr sz="1050" b="1" i="0">
+                <a:solidFill>
+                  <a:srgbClr val="3A6B49"/>
                 </a:solidFill>
                 <a:latin typeface="Consolas"/>
               </a:rPr>
-              <a:t>IN PLACE</a:t>
+              <a:t>FAMILIAR GROUND, NEW TOOLS</a:t>
             </a:r>
           </a:p>
           <a:p>
             <a:pPr algn="l">
               <a:spcBef>
-                <a:spcPts val="700"/>
-              </a:spcBef>
-              <a:spcAft>
-                <a:spcPts val="0"/>
-              </a:spcAft>
-            </a:pPr>
-            <a:r>
-              <a:rPr sz="1500" b="0" i="0">
+                <a:spcPts val="200"/>
+              </a:spcBef>
+              <a:spcAft>
+                <a:spcPts val="0"/>
+              </a:spcAft>
+            </a:pPr>
+            <a:r>
+              <a:rPr sz="1250" b="0" i="0">
                 <a:solidFill>
                   <a:srgbClr val="454E3E"/>
                 </a:solidFill>
                 <a:latin typeface="Calibri"/>
               </a:rPr>
-              <a:t>•  Working local stack: React ⇄ Flask ⇄ SQL Server</a:t>
-            </a:r>
-          </a:p>
-          <a:p>
-            <a:pPr algn="l">
-              <a:spcBef>
-                <a:spcPts val="700"/>
-              </a:spcBef>
-              <a:spcAft>
-                <a:spcPts val="0"/>
-              </a:spcAft>
-            </a:pPr>
-            <a:r>
-              <a:rPr sz="1500" b="0" i="0">
-                <a:solidFill>
-                  <a:srgbClr val="454E3E"/>
-                </a:solidFill>
-                <a:latin typeface="Calibri"/>
-              </a:rPr>
-              <a:t>•  Reproducible database: schema.sql + re-runnable seed.py</a:t>
-            </a:r>
-          </a:p>
-          <a:p>
-            <a:pPr algn="l">
-              <a:spcBef>
-                <a:spcPts val="700"/>
-              </a:spcBef>
-              <a:spcAft>
-                <a:spcPts val="0"/>
-              </a:spcAft>
-            </a:pPr>
-            <a:r>
-              <a:rPr sz="1500" b="0" i="0">
-                <a:solidFill>
-                  <a:srgbClr val="454E3E"/>
-                </a:solidFill>
-                <a:latin typeface="Calibri"/>
-              </a:rPr>
-              <a:t>•  Two repos, README, API reference, technical summary — all in-repo</a:t>
+              <a:t>I'd built back ends before in another language, so REST APIs, routing and working with a database were ideas I already had. Picking up Python and Flask was new syntax over familiar concepts — not starting from zero.</a:t>
             </a:r>
           </a:p>
         </p:txBody>
@@ -6841,8 +6547,8 @@
         </p:nvSpPr>
         <p:spPr>
           <a:xfrm>
-            <a:off x="6720840" y="2103120"/>
-            <a:ext cx="4663440" cy="2743200"/>
+            <a:off x="777240" y="2852928"/>
+            <a:ext cx="10637215" cy="1143000"/>
           </a:xfrm>
           <a:prstGeom prst="rect">
             <a:avLst/>
@@ -6860,93 +6566,36 @@
                 <a:spcPts val="600"/>
               </a:spcBef>
               <a:spcAft>
-                <a:spcPts val="400"/>
-              </a:spcAft>
-            </a:pPr>
-            <a:r>
-              <a:rPr sz="1100" b="1" i="0">
-                <a:solidFill>
-                  <a:srgbClr val="8B8676"/>
+                <a:spcPts val="200"/>
+              </a:spcAft>
+            </a:pPr>
+            <a:r>
+              <a:rPr sz="1050" b="1" i="0">
+                <a:solidFill>
+                  <a:srgbClr val="3A6B49"/>
                 </a:solidFill>
                 <a:latin typeface="Consolas"/>
               </a:rPr>
-              <a:t>IN PROGRESS</a:t>
+              <a:t>A SHIFT I DIDN'T EXPECT</a:t>
             </a:r>
           </a:p>
           <a:p>
             <a:pPr algn="l">
               <a:spcBef>
-                <a:spcPts val="700"/>
-              </a:spcBef>
-              <a:spcAft>
-                <a:spcPts val="0"/>
-              </a:spcAft>
-            </a:pPr>
-            <a:r>
-              <a:rPr sz="1500" b="0" i="0">
-                <a:solidFill>
-                  <a:srgbClr val="8B8676"/>
+                <a:spcPts val="200"/>
+              </a:spcBef>
+              <a:spcAft>
+                <a:spcPts val="0"/>
+              </a:spcAft>
+            </a:pPr>
+            <a:r>
+              <a:rPr sz="1250" b="0" i="0">
+                <a:solidFill>
+                  <a:srgbClr val="454E3E"/>
                 </a:solidFill>
                 <a:latin typeface="Calibri"/>
               </a:rPr>
-              <a:t>–  Docker — containerise both services</a:t>
-            </a:r>
-          </a:p>
-          <a:p>
-            <a:pPr algn="l">
-              <a:spcBef>
-                <a:spcPts val="700"/>
-              </a:spcBef>
-              <a:spcAft>
-                <a:spcPts val="0"/>
-              </a:spcAft>
-            </a:pPr>
-            <a:r>
-              <a:rPr sz="1500" b="0" i="0">
-                <a:solidFill>
-                  <a:srgbClr val="8B8676"/>
-                </a:solidFill>
-                <a:latin typeface="Calibri"/>
-              </a:rPr>
-              <a:t>–  GitHub Actions — build + checks on push</a:t>
-            </a:r>
-          </a:p>
-          <a:p>
-            <a:pPr algn="l">
-              <a:spcBef>
-                <a:spcPts val="700"/>
-              </a:spcBef>
-              <a:spcAft>
-                <a:spcPts val="0"/>
-              </a:spcAft>
-            </a:pPr>
-            <a:r>
-              <a:rPr sz="1500" b="0" i="0">
-                <a:solidFill>
-                  <a:srgbClr val="8B8676"/>
-                </a:solidFill>
-                <a:latin typeface="Calibri"/>
-              </a:rPr>
-              <a:t>–  Terraform — the AWS stack as code</a:t>
-            </a:r>
-          </a:p>
-          <a:p>
-            <a:pPr algn="l">
-              <a:spcBef>
-                <a:spcPts val="700"/>
-              </a:spcBef>
-              <a:spcAft>
-                <a:spcPts val="0"/>
-              </a:spcAft>
-            </a:pPr>
-            <a:r>
-              <a:rPr sz="1500" b="0" i="0">
-                <a:solidFill>
-                  <a:srgbClr val="8B8676"/>
-                </a:solidFill>
-                <a:latin typeface="Calibri"/>
-              </a:rPr>
-              <a:t>–  AWS — deploy, wire a working URL</a:t>
+              <a:t>I went in not expecting to enjoy frontend work. React changed that — thinking in components, with hooks and state, made building the UI feel structured rather than fiddly.</a:t>
             </a:r>
           </a:p>
         </p:txBody>
@@ -6959,8 +6608,8 @@
         </p:nvSpPr>
         <p:spPr>
           <a:xfrm>
-            <a:off x="777240" y="5029200"/>
-            <a:ext cx="10637215" cy="1188720"/>
+            <a:off x="777240" y="3968496"/>
+            <a:ext cx="10637215" cy="1143000"/>
           </a:xfrm>
           <a:prstGeom prst="rect">
             <a:avLst/>
@@ -6978,17 +6627,36 @@
                 <a:spcPts val="600"/>
               </a:spcBef>
               <a:spcAft>
-                <a:spcPts val="0"/>
-              </a:spcAft>
-            </a:pPr>
-            <a:r>
-              <a:rPr sz="1350" b="0" i="0">
+                <a:spcPts val="200"/>
+              </a:spcAft>
+            </a:pPr>
+            <a:r>
+              <a:rPr sz="1050" b="1" i="0">
+                <a:solidFill>
+                  <a:srgbClr val="3A6B49"/>
+                </a:solidFill>
+                <a:latin typeface="Consolas"/>
+              </a:rPr>
+              <a:t>THE HARDEST PART</a:t>
+            </a:r>
+          </a:p>
+          <a:p>
+            <a:pPr algn="l">
+              <a:spcBef>
+                <a:spcPts val="200"/>
+              </a:spcBef>
+              <a:spcAft>
+                <a:spcPts val="0"/>
+              </a:spcAft>
+            </a:pPr>
+            <a:r>
+              <a:rPr sz="1250" b="0" i="0">
                 <a:solidFill>
                   <a:srgbClr val="454E3E"/>
                 </a:solidFill>
                 <a:latin typeface="Calibri"/>
               </a:rPr>
-              <a:t>The application carries 62% of the marks, so I built it first, then applied the cloud training — Terraform describes the AWS stack once, in code, instead of a manual click-through: GitHub change → CI → image → Terraform-managed AWS service.</a:t>
+              <a:t>Deploying to AWS — the number of services and manual console steps, and how easy it is to get one wrong.</a:t>
             </a:r>
           </a:p>
         </p:txBody>
@@ -7001,8 +6669,8 @@
         </p:nvSpPr>
         <p:spPr>
           <a:xfrm>
-            <a:off x="777240" y="6400800"/>
-            <a:ext cx="10637215" cy="320040"/>
+            <a:off x="777240" y="5084064"/>
+            <a:ext cx="10637215" cy="1143000"/>
           </a:xfrm>
           <a:prstGeom prst="rect">
             <a:avLst/>
@@ -7020,17 +6688,36 @@
                 <a:spcPts val="600"/>
               </a:spcBef>
               <a:spcAft>
-                <a:spcPts val="0"/>
-              </a:spcAft>
-            </a:pPr>
-            <a:r>
-              <a:rPr sz="900" b="0" i="0">
-                <a:solidFill>
-                  <a:srgbClr val="8B8676"/>
+                <a:spcPts val="200"/>
+              </a:spcAft>
+            </a:pPr>
+            <a:r>
+              <a:rPr sz="1050" b="1" i="0">
+                <a:solidFill>
+                  <a:srgbClr val="3A6B49"/>
                 </a:solidFill>
                 <a:latin typeface="Consolas"/>
               </a:rPr>
-              <a:t>StockGuard   ·   Thembelihle Zulu   ·   Sanlam 2026 Capstone</a:t>
+              <a:t>WHAT CLICKED, AND WHAT'S NEXT</a:t>
+            </a:r>
+          </a:p>
+          <a:p>
+            <a:pPr algn="l">
+              <a:spcBef>
+                <a:spcPts val="200"/>
+              </a:spcBef>
+              <a:spcAft>
+                <a:spcPts val="0"/>
+              </a:spcAft>
+            </a:pPr>
+            <a:r>
+              <a:rPr sz="1250" b="0" i="0">
+                <a:solidFill>
+                  <a:srgbClr val="454E3E"/>
+                </a:solidFill>
+                <a:latin typeface="Calibri"/>
+              </a:rPr>
+              <a:t>Deploying by hand was like cooking from memory every time — miss a step and it's wrong. Terraform is writing the recipe down: the whole stack in code, so it runs the same way twice. Next I want to go deeper on React patterns and Terraform modules.</a:t>
             </a:r>
           </a:p>
         </p:txBody>
@@ -7043,8 +6730,8 @@
         </p:nvSpPr>
         <p:spPr>
           <a:xfrm>
-            <a:off x="10317175" y="6400800"/>
-            <a:ext cx="1097280" cy="320040"/>
+            <a:off x="777240" y="6400800"/>
+            <a:ext cx="10637215" cy="320040"/>
           </a:xfrm>
           <a:prstGeom prst="rect">
             <a:avLst/>
@@ -7057,7 +6744,7 @@
           </a:bodyPr>
           <a:lstStyle/>
           <a:p>
-            <a:pPr algn="r">
+            <a:pPr algn="l">
               <a:spcBef>
                 <a:spcPts val="600"/>
               </a:spcBef>
@@ -7072,83 +6759,21 @@
                 </a:solidFill>
                 <a:latin typeface="Consolas"/>
               </a:rPr>
-              <a:t>07 / 08</a:t>
-            </a:r>
-          </a:p>
-        </p:txBody>
-      </p:sp>
-    </p:spTree>
-  </p:cSld>
-  <p:clrMapOvr>
-    <a:masterClrMapping/>
-  </p:clrMapOvr>
-</p:sld>
-</file>
-
-<file path=ppt/slides/slide8.xml><?xml version="1.0" encoding="utf-8"?>
-<p:sld xmlns:a="http://schemas.openxmlformats.org/drawingml/2006/main" xmlns:p="http://schemas.openxmlformats.org/presentationml/2006/main" xmlns:r="http://schemas.openxmlformats.org/officeDocument/2006/relationships">
-  <p:cSld>
-    <p:spTree>
-      <p:nvGrpSpPr>
-        <p:cNvPr id="1" name=""/>
-        <p:cNvGrpSpPr/>
-        <p:nvPr/>
-      </p:nvGrpSpPr>
-      <p:grpSpPr/>
-      <p:sp>
-        <p:nvSpPr>
-          <p:cNvPr id="2" name="Rectangle 1"/>
-          <p:cNvSpPr/>
-          <p:nvPr/>
-        </p:nvSpPr>
-        <p:spPr>
-          <a:xfrm>
-            <a:off x="0" y="0"/>
-            <a:ext cx="12191695" cy="6858000"/>
-          </a:xfrm>
-          <a:prstGeom prst="rect">
-            <a:avLst/>
-          </a:prstGeom>
-          <a:solidFill>
-            <a:srgbClr val="F6F4EE"/>
-          </a:solidFill>
-          <a:ln>
-            <a:noFill/>
-          </a:ln>
-          <a:effectLst/>
-        </p:spPr>
-        <p:style>
-          <a:lnRef idx="1">
-            <a:schemeClr val="accent1"/>
-          </a:lnRef>
-          <a:fillRef idx="3">
-            <a:schemeClr val="accent1"/>
-          </a:fillRef>
-          <a:effectRef idx="2">
-            <a:schemeClr val="accent1"/>
-          </a:effectRef>
-          <a:fontRef idx="minor">
-            <a:schemeClr val="lt1"/>
-          </a:fontRef>
-        </p:style>
-        <p:txBody>
-          <a:bodyPr rtlCol="0" anchor="ctr"/>
-          <a:lstStyle/>
-          <a:p>
-            <a:pPr algn="ctr"/>
-          </a:p>
-        </p:txBody>
-      </p:sp>
-      <p:sp>
-        <p:nvSpPr>
-          <p:cNvPr id="3" name="TextBox 2"/>
+              <a:t>StockGuard   ·   Thembelihle Zulu   ·   Sanlam 2026 Capstone</a:t>
+            </a:r>
+          </a:p>
+        </p:txBody>
+      </p:sp>
+      <p:sp>
+        <p:nvSpPr>
+          <p:cNvPr id="11" name="TextBox 10"/>
           <p:cNvSpPr txBox="1"/>
           <p:nvPr/>
         </p:nvSpPr>
         <p:spPr>
           <a:xfrm>
-            <a:off x="777240" y="457200"/>
-            <a:ext cx="10637215" cy="365760"/>
+            <a:off x="10225735" y="6400800"/>
+            <a:ext cx="1188720" cy="320040"/>
           </a:xfrm>
           <a:prstGeom prst="rect">
             <a:avLst/>
@@ -7161,7 +6786,7 @@
           </a:bodyPr>
           <a:lstStyle/>
           <a:p>
-            <a:pPr algn="l">
+            <a:pPr algn="r">
               <a:spcBef>
                 <a:spcPts val="600"/>
               </a:spcBef>
@@ -7170,425 +6795,13 @@
               </a:spcAft>
             </a:pPr>
             <a:r>
-              <a:rPr sz="1200" b="1" i="0">
-                <a:solidFill>
-                  <a:srgbClr val="3A6B49"/>
+              <a:rPr sz="900" b="0" i="0">
+                <a:solidFill>
+                  <a:srgbClr val="8B8676"/>
                 </a:solidFill>
                 <a:latin typeface="Consolas"/>
               </a:rPr>
-              <a:t>PERSONAL REFLECTION</a:t>
-            </a:r>
-          </a:p>
-        </p:txBody>
-      </p:sp>
-      <p:sp>
-        <p:nvSpPr>
-          <p:cNvPr id="4" name="TextBox 3"/>
-          <p:cNvSpPr txBox="1"/>
-          <p:nvPr/>
-        </p:nvSpPr>
-        <p:spPr>
-          <a:xfrm>
-            <a:off x="10042855" y="457200"/>
-            <a:ext cx="1371600" cy="365760"/>
-          </a:xfrm>
-          <a:prstGeom prst="rect">
-            <a:avLst/>
-          </a:prstGeom>
-          <a:noFill/>
-        </p:spPr>
-        <p:txBody>
-          <a:bodyPr wrap="square" anchor="t">
-            <a:spAutoFit/>
-          </a:bodyPr>
-          <a:lstStyle/>
-          <a:p>
-            <a:pPr algn="r">
-              <a:spcBef>
-                <a:spcPts val="600"/>
-              </a:spcBef>
-              <a:spcAft>
-                <a:spcPts val="0"/>
-              </a:spcAft>
-            </a:pPr>
-            <a:r>
-              <a:rPr sz="1200" b="0" i="0">
-                <a:solidFill>
-                  <a:srgbClr val="8B8676"/>
-                </a:solidFill>
-                <a:latin typeface="Consolas"/>
-              </a:rPr>
-              <a:t>08 / 08</a:t>
-            </a:r>
-          </a:p>
-        </p:txBody>
-      </p:sp>
-      <p:sp>
-        <p:nvSpPr>
-          <p:cNvPr id="5" name="TextBox 4"/>
-          <p:cNvSpPr txBox="1"/>
-          <p:nvPr/>
-        </p:nvSpPr>
-        <p:spPr>
-          <a:xfrm>
-            <a:off x="777240" y="960120"/>
-            <a:ext cx="10637215" cy="822960"/>
-          </a:xfrm>
-          <a:prstGeom prst="rect">
-            <a:avLst/>
-          </a:prstGeom>
-          <a:noFill/>
-        </p:spPr>
-        <p:txBody>
-          <a:bodyPr wrap="square" anchor="t">
-            <a:spAutoFit/>
-          </a:bodyPr>
-          <a:lstStyle/>
-          <a:p>
-            <a:pPr algn="l">
-              <a:spcBef>
-                <a:spcPts val="600"/>
-              </a:spcBef>
-              <a:spcAft>
-                <a:spcPts val="0"/>
-              </a:spcAft>
-            </a:pPr>
-            <a:r>
-              <a:rPr sz="2500" b="1" i="0">
-                <a:solidFill>
-                  <a:srgbClr val="1B2318"/>
-                </a:solidFill>
-                <a:latin typeface="Georgia"/>
-              </a:rPr>
-              <a:t>What the training changed about how I work.</a:t>
-            </a:r>
-          </a:p>
-        </p:txBody>
-      </p:sp>
-      <p:sp>
-        <p:nvSpPr>
-          <p:cNvPr id="6" name="TextBox 5"/>
-          <p:cNvSpPr txBox="1"/>
-          <p:nvPr/>
-        </p:nvSpPr>
-        <p:spPr>
-          <a:xfrm>
-            <a:off x="777240" y="1828800"/>
-            <a:ext cx="10637215" cy="1143000"/>
-          </a:xfrm>
-          <a:prstGeom prst="rect">
-            <a:avLst/>
-          </a:prstGeom>
-          <a:noFill/>
-        </p:spPr>
-        <p:txBody>
-          <a:bodyPr wrap="square" anchor="t">
-            <a:spAutoFit/>
-          </a:bodyPr>
-          <a:lstStyle/>
-          <a:p>
-            <a:pPr algn="l">
-              <a:spcBef>
-                <a:spcPts val="600"/>
-              </a:spcBef>
-              <a:spcAft>
-                <a:spcPts val="200"/>
-              </a:spcAft>
-            </a:pPr>
-            <a:r>
-              <a:rPr sz="1050" b="1" i="0">
-                <a:solidFill>
-                  <a:srgbClr val="3A6B49"/>
-                </a:solidFill>
-                <a:latin typeface="Consolas"/>
-              </a:rPr>
-              <a:t>WHERE I STARTED STRONG</a:t>
-            </a:r>
-          </a:p>
-          <a:p>
-            <a:pPr algn="l">
-              <a:spcBef>
-                <a:spcPts val="200"/>
-              </a:spcBef>
-              <a:spcAft>
-                <a:spcPts val="0"/>
-              </a:spcAft>
-            </a:pPr>
-            <a:r>
-              <a:rPr sz="1250" b="0" i="0">
-                <a:solidFill>
-                  <a:srgbClr val="454E3E"/>
-                </a:solidFill>
-                <a:latin typeface="Calibri"/>
-              </a:rPr>
-              <a:t>The backend — Flask, REST API design, SQL data modelling and auth. This is where I was most comfortable from day one and where I did my sharpest work.</a:t>
-            </a:r>
-          </a:p>
-        </p:txBody>
-      </p:sp>
-      <p:sp>
-        <p:nvSpPr>
-          <p:cNvPr id="7" name="TextBox 6"/>
-          <p:cNvSpPr txBox="1"/>
-          <p:nvPr/>
-        </p:nvSpPr>
-        <p:spPr>
-          <a:xfrm>
-            <a:off x="777240" y="2944368"/>
-            <a:ext cx="10637215" cy="1143000"/>
-          </a:xfrm>
-          <a:prstGeom prst="rect">
-            <a:avLst/>
-          </a:prstGeom>
-          <a:noFill/>
-        </p:spPr>
-        <p:txBody>
-          <a:bodyPr wrap="square" anchor="t">
-            <a:spAutoFit/>
-          </a:bodyPr>
-          <a:lstStyle/>
-          <a:p>
-            <a:pPr algn="l">
-              <a:spcBef>
-                <a:spcPts val="600"/>
-              </a:spcBef>
-              <a:spcAft>
-                <a:spcPts val="200"/>
-              </a:spcAft>
-            </a:pPr>
-            <a:r>
-              <a:rPr sz="1050" b="1" i="0">
-                <a:solidFill>
-                  <a:srgbClr val="3A6B49"/>
-                </a:solidFill>
-                <a:latin typeface="Consolas"/>
-              </a:rPr>
-              <a:t>A SHIFT I DIDN'T EXPECT</a:t>
-            </a:r>
-          </a:p>
-          <a:p>
-            <a:pPr algn="l">
-              <a:spcBef>
-                <a:spcPts val="200"/>
-              </a:spcBef>
-              <a:spcAft>
-                <a:spcPts val="0"/>
-              </a:spcAft>
-            </a:pPr>
-            <a:r>
-              <a:rPr sz="1250" b="0" i="0">
-                <a:solidFill>
-                  <a:srgbClr val="454E3E"/>
-                </a:solidFill>
-                <a:latin typeface="Calibri"/>
-              </a:rPr>
-              <a:t>I went in not expecting to enjoy frontend work. React changed that — thinking in components, and using hooks and state, made building the UI feel structured rather than fiddly.</a:t>
-            </a:r>
-          </a:p>
-        </p:txBody>
-      </p:sp>
-      <p:sp>
-        <p:nvSpPr>
-          <p:cNvPr id="8" name="TextBox 7"/>
-          <p:cNvSpPr txBox="1"/>
-          <p:nvPr/>
-        </p:nvSpPr>
-        <p:spPr>
-          <a:xfrm>
-            <a:off x="777240" y="4059936"/>
-            <a:ext cx="10637215" cy="1143000"/>
-          </a:xfrm>
-          <a:prstGeom prst="rect">
-            <a:avLst/>
-          </a:prstGeom>
-          <a:noFill/>
-        </p:spPr>
-        <p:txBody>
-          <a:bodyPr wrap="square" anchor="t">
-            <a:spAutoFit/>
-          </a:bodyPr>
-          <a:lstStyle/>
-          <a:p>
-            <a:pPr algn="l">
-              <a:spcBef>
-                <a:spcPts val="600"/>
-              </a:spcBef>
-              <a:spcAft>
-                <a:spcPts val="200"/>
-              </a:spcAft>
-            </a:pPr>
-            <a:r>
-              <a:rPr sz="1050" b="1" i="0">
-                <a:solidFill>
-                  <a:srgbClr val="3A6B49"/>
-                </a:solidFill>
-                <a:latin typeface="Consolas"/>
-              </a:rPr>
-              <a:t>THE HARDEST PART, AND MY RESPONSE</a:t>
-            </a:r>
-          </a:p>
-          <a:p>
-            <a:pPr algn="l">
-              <a:spcBef>
-                <a:spcPts val="200"/>
-              </a:spcBef>
-              <a:spcAft>
-                <a:spcPts val="0"/>
-              </a:spcAft>
-            </a:pPr>
-            <a:r>
-              <a:rPr sz="1250" b="0" i="0">
-                <a:solidFill>
-                  <a:srgbClr val="454E3E"/>
-                </a:solidFill>
-                <a:latin typeface="Calibri"/>
-              </a:rPr>
-              <a:t>Deploying to AWS — the number of services and manual console steps to wire together, and how easy it is to get one wrong. I leaned into Terraform so the whole stack is written once, in code.</a:t>
-            </a:r>
-          </a:p>
-        </p:txBody>
-      </p:sp>
-      <p:sp>
-        <p:nvSpPr>
-          <p:cNvPr id="9" name="TextBox 8"/>
-          <p:cNvSpPr txBox="1"/>
-          <p:nvPr/>
-        </p:nvSpPr>
-        <p:spPr>
-          <a:xfrm>
-            <a:off x="777240" y="5175504"/>
-            <a:ext cx="10637215" cy="1143000"/>
-          </a:xfrm>
-          <a:prstGeom prst="rect">
-            <a:avLst/>
-          </a:prstGeom>
-          <a:noFill/>
-        </p:spPr>
-        <p:txBody>
-          <a:bodyPr wrap="square" anchor="t">
-            <a:spAutoFit/>
-          </a:bodyPr>
-          <a:lstStyle/>
-          <a:p>
-            <a:pPr algn="l">
-              <a:spcBef>
-                <a:spcPts val="600"/>
-              </a:spcBef>
-              <a:spcAft>
-                <a:spcPts val="200"/>
-              </a:spcAft>
-            </a:pPr>
-            <a:r>
-              <a:rPr sz="1050" b="1" i="0">
-                <a:solidFill>
-                  <a:srgbClr val="3A6B49"/>
-                </a:solidFill>
-                <a:latin typeface="Consolas"/>
-              </a:rPr>
-              <a:t>KEY LEARNING &amp; NEXT GOAL</a:t>
-            </a:r>
-          </a:p>
-          <a:p>
-            <a:pPr algn="l">
-              <a:spcBef>
-                <a:spcPts val="200"/>
-              </a:spcBef>
-              <a:spcAft>
-                <a:spcPts val="0"/>
-              </a:spcAft>
-            </a:pPr>
-            <a:r>
-              <a:rPr sz="1250" b="0" i="0">
-                <a:solidFill>
-                  <a:srgbClr val="454E3E"/>
-                </a:solidFill>
-                <a:latin typeface="Calibri"/>
-              </a:rPr>
-              <a:t>Infrastructure as code: a Terraform config is repeatable and reviewable, not a click-through I have to redo from memory. Next I want to go deeper on the two areas that surprised me most — React patterns and Terraform modules.</a:t>
-            </a:r>
-          </a:p>
-        </p:txBody>
-      </p:sp>
-      <p:sp>
-        <p:nvSpPr>
-          <p:cNvPr id="10" name="TextBox 9"/>
-          <p:cNvSpPr txBox="1"/>
-          <p:nvPr/>
-        </p:nvSpPr>
-        <p:spPr>
-          <a:xfrm>
-            <a:off x="777240" y="6400800"/>
-            <a:ext cx="10637215" cy="320040"/>
-          </a:xfrm>
-          <a:prstGeom prst="rect">
-            <a:avLst/>
-          </a:prstGeom>
-          <a:noFill/>
-        </p:spPr>
-        <p:txBody>
-          <a:bodyPr wrap="square" anchor="t">
-            <a:spAutoFit/>
-          </a:bodyPr>
-          <a:lstStyle/>
-          <a:p>
-            <a:pPr algn="l">
-              <a:spcBef>
-                <a:spcPts val="600"/>
-              </a:spcBef>
-              <a:spcAft>
-                <a:spcPts val="0"/>
-              </a:spcAft>
-            </a:pPr>
-            <a:r>
-              <a:rPr sz="900" b="0" i="0">
-                <a:solidFill>
-                  <a:srgbClr val="8B8676"/>
-                </a:solidFill>
-                <a:latin typeface="Consolas"/>
-              </a:rPr>
-              <a:t>StockGuard   ·   Thembelihle Zulu   ·   Sanlam 2026 Capstone</a:t>
-            </a:r>
-          </a:p>
-        </p:txBody>
-      </p:sp>
-      <p:sp>
-        <p:nvSpPr>
-          <p:cNvPr id="11" name="TextBox 10"/>
-          <p:cNvSpPr txBox="1"/>
-          <p:nvPr/>
-        </p:nvSpPr>
-        <p:spPr>
-          <a:xfrm>
-            <a:off x="10317175" y="6400800"/>
-            <a:ext cx="1097280" cy="320040"/>
-          </a:xfrm>
-          <a:prstGeom prst="rect">
-            <a:avLst/>
-          </a:prstGeom>
-          <a:noFill/>
-        </p:spPr>
-        <p:txBody>
-          <a:bodyPr wrap="square" anchor="t">
-            <a:spAutoFit/>
-          </a:bodyPr>
-          <a:lstStyle/>
-          <a:p>
-            <a:pPr algn="r">
-              <a:spcBef>
-                <a:spcPts val="600"/>
-              </a:spcBef>
-              <a:spcAft>
-                <a:spcPts val="0"/>
-              </a:spcAft>
-            </a:pPr>
-            <a:r>
-              <a:rPr sz="900" b="0" i="0">
-                <a:solidFill>
-                  <a:srgbClr val="8B8676"/>
-                </a:solidFill>
-                <a:latin typeface="Consolas"/>
-              </a:rPr>
-              <a:t>08 / 08</a:t>
+              <a:t>07 / 07</a:t>
             </a:r>
           </a:p>
         </p:txBody>

</xml_diff>